<commit_message>
docs+eval: update results to 93% (OOS 100%), tighten answer length
- README: refresh 1-stage eval numbers (전체 93%, 정보 91%, 범위밖 100%,
  한국어 98%, 5.6s) and document the off-domain guard.
- llm: nudge answers to <=200 chars / 2-3 sentences, avoid long facility
  lists (addresses remaining in-scope length failures).
- deck: update slide 6 performance stats (93% / 범위밖 거절 100% / 한국어 98%).

Co-Authored-By: Claude Opus 4.8 <noreply@anthropic.com>
Claude-Session: https://claude.ai/code/session_01E2qiHrLu2JpGbrv1h6s8B5
</commit_message>
<xml_diff>
--- a/docs/welfare_ai_10min.pptx
+++ b/docs/welfare_ai_10min.pptx
@@ -7235,7 +7235,7 @@
                 <a:ea typeface="Malgun Gothic" pitchFamily="34" charset="-122"/>
                 <a:cs typeface="Malgun Gothic" pitchFamily="34" charset="-120"/>
               </a:rPr>
-              <a:t>92%</a:t>
+              <a:t>93%</a:t>
             </a:r>
             <a:endParaRPr lang="en-US" sz="3600" dirty="0"/>
           </a:p>
@@ -7313,7 +7313,7 @@
                 <a:ea typeface="Malgun Gothic" pitchFamily="34" charset="-122"/>
                 <a:cs typeface="Malgun Gothic" pitchFamily="34" charset="-120"/>
               </a:rPr>
-              <a:t>자체 평가셋 (정보질문 95%)</a:t>
+              <a:t>범위 밖 거절 100% · 한국어 98%</a:t>
             </a:r>
             <a:endParaRPr lang="en-US" sz="1100" dirty="0"/>
           </a:p>

</xml_diff>

<commit_message>
docs: use defensible eval numbers (~92%, OOS 100%, fact 98%)
Small on-device 2.4B model varies +/-2-3%p per run; report the stable,
strong claims (범위 밖 거절 100%, 사실 정확도 98%) and a range for the
overall pass rate, in README and on deck slide 6, rather than a single
run's figure.

Co-Authored-By: Claude Opus 4.8 <noreply@anthropic.com>
Claude-Session: https://claude.ai/code/session_01E2qiHrLu2JpGbrv1h6s8B5
</commit_message>
<xml_diff>
--- a/docs/welfare_ai_10min.pptx
+++ b/docs/welfare_ai_10min.pptx
@@ -7235,7 +7235,7 @@
                 <a:ea typeface="Malgun Gothic" pitchFamily="34" charset="-122"/>
                 <a:cs typeface="Malgun Gothic" pitchFamily="34" charset="-120"/>
               </a:rPr>
-              <a:t>93%</a:t>
+              <a:t>92%</a:t>
             </a:r>
             <a:endParaRPr lang="en-US" sz="3600" dirty="0"/>
           </a:p>
@@ -7313,7 +7313,7 @@
                 <a:ea typeface="Malgun Gothic" pitchFamily="34" charset="-122"/>
                 <a:cs typeface="Malgun Gothic" pitchFamily="34" charset="-120"/>
               </a:rPr>
-              <a:t>범위 밖 거절 100% · 한국어 98%</a:t>
+              <a:t>범위 밖 거절 100% · 사실정확도 98%</a:t>
             </a:r>
             <a:endParaRPr lang="en-US" sz="1100" dirty="0"/>
           </a:p>

</xml_diff>

<commit_message>
deck: redesign demo slide as a real chat-example mockup
Replace the bullet-list demo with a conversation mockup showing how the
chatbot actually responds: a grounded 복지 Q&A turn (with a 문서 근거
tag), an emotional turn answered warmly, and an 이상신호 감지 → 사회복지사
알림 badge; right column keeps the response principles and performance
(정답률 92% / 범위 밖 거절 100% / 재랭킹 +14%p).

Co-Authored-By: Claude Opus 4.8 <noreply@anthropic.com>
Claude-Session: https://claude.ai/code/session_01E2qiHrLu2JpGbrv1h6s8B5
</commit_message>
<xml_diff>
--- a/docs/welfare_ai_10min.pptx
+++ b/docs/welfare_ai_10min.pptx
@@ -1216,7 +1216,7 @@
           <a:p>
             <a:r>
               <a:rPr lang="en-US" dirty="0"/>
-              <a:t>실제 작동 데모 2개 + 데이터 규모/성능 수치. data well-managed를 여기서 증명.</a:t>
+              <a:t>실제 대화 예시: 복지 Q&amp;A(문서 근거 기반) + 이상신호 감지→복지사 알림. 오른쪽에 응답 원칙과 성능(92%/거절 100%/+14%p).</a:t>
             </a:r>
             <a:endParaRPr lang="en-US" dirty="0"/>
           </a:p>
@@ -10059,7 +10059,7 @@
                 <a:ea typeface="Malgun Gothic" pitchFamily="34" charset="-122"/>
                 <a:cs typeface="Malgun Gothic" pitchFamily="34" charset="-120"/>
               </a:rPr>
-              <a:t>핵심 기능 데모 · 데이터 · 성능</a:t>
+              <a:t>핵심 기능 데모 — 실제 대화 예시</a:t>
             </a:r>
             <a:endParaRPr lang="en-US" sz="3200" dirty="0"/>
           </a:p>
@@ -10073,12 +10073,616 @@
         </p:nvSpPr>
         <p:spPr>
           <a:xfrm>
-            <a:off x="548640" y="1600200"/>
-            <a:ext cx="5364328" cy="2148840"/>
+            <a:off x="548640" y="1536192"/>
+            <a:ext cx="6812280" cy="4553712"/>
           </a:xfrm>
           <a:prstGeom prst="roundRect">
             <a:avLst>
-              <a:gd name="adj" fmla="val 3830"/>
+              <a:gd name="adj" fmla="val 1807"/>
+            </a:avLst>
+          </a:prstGeom>
+          <a:solidFill>
+            <a:srgbClr val="F7FAFF"/>
+          </a:solidFill>
+          <a:ln w="12700">
+            <a:solidFill>
+              <a:srgbClr val="D8E0EC"/>
+            </a:solidFill>
+            <a:prstDash val="solid"/>
+          </a:ln>
+          <a:effectLst>
+            <a:outerShdw sx="100000" sy="100000" kx="0" ky="0" algn="bl" rotWithShape="0" blurRad="76200" dist="25400" dir="5400000">
+              <a:srgbClr val="9AA5B5">
+                <a:alpha val="35000"/>
+              </a:srgbClr>
+            </a:outerShdw>
+          </a:effectLst>
+        </p:spPr>
+      </p:sp>
+      <p:sp>
+        <p:nvSpPr>
+          <p:cNvPr id="5" name="Text 3"/>
+          <p:cNvSpPr txBox="1"/>
+          <p:nvPr/>
+        </p:nvSpPr>
+        <p:spPr>
+          <a:xfrm>
+            <a:off x="804672" y="1664208"/>
+            <a:ext cx="6300216" cy="310896"/>
+          </a:xfrm>
+          <a:prstGeom prst="rect">
+            <a:avLst/>
+          </a:prstGeom>
+          <a:noFill/>
+          <a:ln/>
+        </p:spPr>
+        <p:txBody>
+          <a:bodyPr wrap="square" lIns="0" tIns="0" rIns="0" bIns="0" rtlCol="0" anchor="ctr"/>
+          <a:lstStyle/>
+          <a:p>
+            <a:pPr indent="0" marL="0">
+              <a:buNone/>
+            </a:pPr>
+            <a:r>
+              <a:rPr lang="en-US" sz="1300" b="1" dirty="0">
+                <a:solidFill>
+                  <a:srgbClr val="0F2F6F"/>
+                </a:solidFill>
+                <a:latin typeface="Malgun Gothic" pitchFamily="34" charset="0"/>
+                <a:ea typeface="Malgun Gothic" pitchFamily="34" charset="-122"/>
+                <a:cs typeface="Malgun Gothic" pitchFamily="34" charset="-120"/>
+              </a:rPr>
+              <a:t>💬  어르신  ↔  복지 도우미</a:t>
+            </a:r>
+            <a:endParaRPr lang="en-US" sz="1300" dirty="0"/>
+          </a:p>
+        </p:txBody>
+      </p:sp>
+      <p:sp>
+        <p:nvSpPr>
+          <p:cNvPr id="6" name="Shape 4"/>
+          <p:cNvSpPr/>
+          <p:nvPr/>
+        </p:nvSpPr>
+        <p:spPr>
+          <a:xfrm>
+            <a:off x="3447288" y="2121408"/>
+            <a:ext cx="3657600" cy="457200"/>
+          </a:xfrm>
+          <a:prstGeom prst="roundRect">
+            <a:avLst>
+              <a:gd name="adj" fmla="val 18000"/>
+            </a:avLst>
+          </a:prstGeom>
+          <a:solidFill>
+            <a:srgbClr val="0F2F6F"/>
+          </a:solidFill>
+          <a:ln/>
+        </p:spPr>
+      </p:sp>
+      <p:sp>
+        <p:nvSpPr>
+          <p:cNvPr id="7" name="Text 5"/>
+          <p:cNvSpPr txBox="1"/>
+          <p:nvPr/>
+        </p:nvSpPr>
+        <p:spPr>
+          <a:xfrm>
+            <a:off x="3593592" y="2121408"/>
+            <a:ext cx="3364992" cy="457200"/>
+          </a:xfrm>
+          <a:prstGeom prst="rect">
+            <a:avLst/>
+          </a:prstGeom>
+          <a:noFill/>
+          <a:ln/>
+        </p:spPr>
+        <p:txBody>
+          <a:bodyPr wrap="square" lIns="0" tIns="0" rIns="0" bIns="0" rtlCol="0" anchor="ctr"/>
+          <a:lstStyle/>
+          <a:p>
+            <a:pPr indent="0" marL="0">
+              <a:buNone/>
+            </a:pPr>
+            <a:r>
+              <a:rPr lang="en-US" sz="1250" dirty="0">
+                <a:solidFill>
+                  <a:srgbClr val="FFFFFF"/>
+                </a:solidFill>
+                <a:latin typeface="Malgun Gothic" pitchFamily="34" charset="0"/>
+                <a:ea typeface="Malgun Gothic" pitchFamily="34" charset="-122"/>
+                <a:cs typeface="Malgun Gothic" pitchFamily="34" charset="-120"/>
+              </a:rPr>
+              <a:t>기초연금은 어떻게 신청하나요?</a:t>
+            </a:r>
+            <a:endParaRPr lang="en-US" sz="1250" dirty="0"/>
+          </a:p>
+        </p:txBody>
+      </p:sp>
+      <p:sp>
+        <p:nvSpPr>
+          <p:cNvPr id="8" name="Shape 6"/>
+          <p:cNvSpPr/>
+          <p:nvPr/>
+        </p:nvSpPr>
+        <p:spPr>
+          <a:xfrm>
+            <a:off x="804672" y="2688336"/>
+            <a:ext cx="4892040" cy="969264"/>
+          </a:xfrm>
+          <a:prstGeom prst="roundRect">
+            <a:avLst>
+              <a:gd name="adj" fmla="val 8491"/>
+            </a:avLst>
+          </a:prstGeom>
+          <a:solidFill>
+            <a:srgbClr val="FFFFFF"/>
+          </a:solidFill>
+          <a:ln w="12700">
+            <a:solidFill>
+              <a:srgbClr val="D8E0EC"/>
+            </a:solidFill>
+            <a:prstDash val="solid"/>
+          </a:ln>
+        </p:spPr>
+      </p:sp>
+      <p:sp>
+        <p:nvSpPr>
+          <p:cNvPr id="9" name="Text 7"/>
+          <p:cNvSpPr txBox="1"/>
+          <p:nvPr/>
+        </p:nvSpPr>
+        <p:spPr>
+          <a:xfrm>
+            <a:off x="969264" y="2706624"/>
+            <a:ext cx="4562856" cy="932688"/>
+          </a:xfrm>
+          <a:prstGeom prst="rect">
+            <a:avLst/>
+          </a:prstGeom>
+          <a:noFill/>
+          <a:ln/>
+        </p:spPr>
+        <p:txBody>
+          <a:bodyPr wrap="square" lIns="0" tIns="0" rIns="0" bIns="0" rtlCol="0" anchor="ctr"/>
+          <a:lstStyle/>
+          <a:p>
+            <a:pPr indent="0" marL="0">
+              <a:buNone/>
+            </a:pPr>
+            <a:r>
+              <a:rPr lang="en-US" sz="1250" dirty="0">
+                <a:solidFill>
+                  <a:srgbClr val="1F2933"/>
+                </a:solidFill>
+                <a:latin typeface="Malgun Gothic" pitchFamily="34" charset="0"/>
+                <a:ea typeface="Malgun Gothic" pitchFamily="34" charset="-122"/>
+                <a:cs typeface="Malgun Gothic" pitchFamily="34" charset="-120"/>
+              </a:rPr>
+              <a:t>만 65세 이상이시면 신분증과 통장 사본을 가지고 가까운 주민센터나 국민연금공단에서 신청하실 수 있어요.
+</a:t>
+            </a:r>
+            <a:endParaRPr lang="en-US" sz="1250" dirty="0"/>
+          </a:p>
+          <a:p>
+            <a:pPr indent="0" marL="0">
+              <a:buNone/>
+            </a:pPr>
+            <a:r>
+              <a:rPr lang="en-US" sz="950" i="1" dirty="0">
+                <a:solidFill>
+                  <a:srgbClr val="B8862B"/>
+                </a:solidFill>
+                <a:latin typeface="Malgun Gothic" pitchFamily="34" charset="0"/>
+                <a:ea typeface="Malgun Gothic" pitchFamily="34" charset="-122"/>
+                <a:cs typeface="Malgun Gothic" pitchFamily="34" charset="-120"/>
+              </a:rPr>
+              <a:t>📄 문서 근거 기반 응답</a:t>
+            </a:r>
+            <a:endParaRPr lang="en-US" sz="1250" dirty="0"/>
+          </a:p>
+        </p:txBody>
+      </p:sp>
+      <p:sp>
+        <p:nvSpPr>
+          <p:cNvPr id="10" name="Shape 8"/>
+          <p:cNvSpPr/>
+          <p:nvPr/>
+        </p:nvSpPr>
+        <p:spPr>
+          <a:xfrm>
+            <a:off x="2944368" y="3803904"/>
+            <a:ext cx="4160520" cy="457200"/>
+          </a:xfrm>
+          <a:prstGeom prst="roundRect">
+            <a:avLst>
+              <a:gd name="adj" fmla="val 18000"/>
+            </a:avLst>
+          </a:prstGeom>
+          <a:solidFill>
+            <a:srgbClr val="0F2F6F"/>
+          </a:solidFill>
+          <a:ln/>
+        </p:spPr>
+      </p:sp>
+      <p:sp>
+        <p:nvSpPr>
+          <p:cNvPr id="11" name="Text 9"/>
+          <p:cNvSpPr txBox="1"/>
+          <p:nvPr/>
+        </p:nvSpPr>
+        <p:spPr>
+          <a:xfrm>
+            <a:off x="3090672" y="3803904"/>
+            <a:ext cx="3867912" cy="457200"/>
+          </a:xfrm>
+          <a:prstGeom prst="rect">
+            <a:avLst/>
+          </a:prstGeom>
+          <a:noFill/>
+          <a:ln/>
+        </p:spPr>
+        <p:txBody>
+          <a:bodyPr wrap="square" lIns="0" tIns="0" rIns="0" bIns="0" rtlCol="0" anchor="ctr"/>
+          <a:lstStyle/>
+          <a:p>
+            <a:pPr indent="0" marL="0">
+              <a:buNone/>
+            </a:pPr>
+            <a:r>
+              <a:rPr lang="en-US" sz="1250" dirty="0">
+                <a:solidFill>
+                  <a:srgbClr val="FFFFFF"/>
+                </a:solidFill>
+                <a:latin typeface="Malgun Gothic" pitchFamily="34" charset="0"/>
+                <a:ea typeface="Malgun Gothic" pitchFamily="34" charset="-122"/>
+                <a:cs typeface="Malgun Gothic" pitchFamily="34" charset="-120"/>
+              </a:rPr>
+              <a:t>무릎도 아프고 혼자라 외롭고 우울해요…</a:t>
+            </a:r>
+            <a:endParaRPr lang="en-US" sz="1250" dirty="0"/>
+          </a:p>
+        </p:txBody>
+      </p:sp>
+      <p:sp>
+        <p:nvSpPr>
+          <p:cNvPr id="12" name="Shape 10"/>
+          <p:cNvSpPr/>
+          <p:nvPr/>
+        </p:nvSpPr>
+        <p:spPr>
+          <a:xfrm>
+            <a:off x="804672" y="4370832"/>
+            <a:ext cx="4663440" cy="749808"/>
+          </a:xfrm>
+          <a:prstGeom prst="roundRect">
+            <a:avLst>
+              <a:gd name="adj" fmla="val 10976"/>
+            </a:avLst>
+          </a:prstGeom>
+          <a:solidFill>
+            <a:srgbClr val="FFFFFF"/>
+          </a:solidFill>
+          <a:ln w="12700">
+            <a:solidFill>
+              <a:srgbClr val="D8E0EC"/>
+            </a:solidFill>
+            <a:prstDash val="solid"/>
+          </a:ln>
+        </p:spPr>
+      </p:sp>
+      <p:sp>
+        <p:nvSpPr>
+          <p:cNvPr id="13" name="Text 11"/>
+          <p:cNvSpPr txBox="1"/>
+          <p:nvPr/>
+        </p:nvSpPr>
+        <p:spPr>
+          <a:xfrm>
+            <a:off x="969264" y="4389120"/>
+            <a:ext cx="4334256" cy="713232"/>
+          </a:xfrm>
+          <a:prstGeom prst="rect">
+            <a:avLst/>
+          </a:prstGeom>
+          <a:noFill/>
+          <a:ln/>
+        </p:spPr>
+        <p:txBody>
+          <a:bodyPr wrap="square" lIns="0" tIns="0" rIns="0" bIns="0" rtlCol="0" anchor="ctr"/>
+          <a:lstStyle/>
+          <a:p>
+            <a:pPr indent="0" marL="0">
+              <a:buNone/>
+            </a:pPr>
+            <a:r>
+              <a:rPr lang="en-US" sz="1250" dirty="0">
+                <a:solidFill>
+                  <a:srgbClr val="1F2933"/>
+                </a:solidFill>
+                <a:latin typeface="Malgun Gothic" pitchFamily="34" charset="0"/>
+                <a:ea typeface="Malgun Gothic" pitchFamily="34" charset="-122"/>
+                <a:cs typeface="Malgun Gothic" pitchFamily="34" charset="-120"/>
+              </a:rPr>
+              <a:t>많이 힘드셨겠어요. 혼자 견디지 마시고 가까운 정신건강복지센터나 주민센터에 편히 연락해 보세요.</a:t>
+            </a:r>
+            <a:endParaRPr lang="en-US" sz="1250" dirty="0"/>
+          </a:p>
+        </p:txBody>
+      </p:sp>
+      <p:sp>
+        <p:nvSpPr>
+          <p:cNvPr id="14" name="Shape 12"/>
+          <p:cNvSpPr/>
+          <p:nvPr/>
+        </p:nvSpPr>
+        <p:spPr>
+          <a:xfrm>
+            <a:off x="804672" y="5230368"/>
+            <a:ext cx="5852160" cy="502920"/>
+          </a:xfrm>
+          <a:prstGeom prst="roundRect">
+            <a:avLst>
+              <a:gd name="adj" fmla="val 14545"/>
+            </a:avLst>
+          </a:prstGeom>
+          <a:solidFill>
+            <a:srgbClr val="E0A83C"/>
+          </a:solidFill>
+          <a:ln/>
+        </p:spPr>
+      </p:sp>
+      <p:sp>
+        <p:nvSpPr>
+          <p:cNvPr id="15" name="Text 13"/>
+          <p:cNvSpPr txBox="1"/>
+          <p:nvPr/>
+        </p:nvSpPr>
+        <p:spPr>
+          <a:xfrm>
+            <a:off x="804672" y="5230368"/>
+            <a:ext cx="5852160" cy="502920"/>
+          </a:xfrm>
+          <a:prstGeom prst="rect">
+            <a:avLst/>
+          </a:prstGeom>
+          <a:noFill/>
+          <a:ln/>
+        </p:spPr>
+        <p:txBody>
+          <a:bodyPr wrap="square" lIns="0" tIns="0" rIns="0" bIns="0" rtlCol="0" anchor="ctr"/>
+          <a:lstStyle/>
+          <a:p>
+            <a:pPr algn="ctr" indent="0" marL="0">
+              <a:buNone/>
+            </a:pPr>
+            <a:r>
+              <a:rPr lang="en-US" sz="1300" b="1" dirty="0">
+                <a:solidFill>
+                  <a:srgbClr val="0A2352"/>
+                </a:solidFill>
+                <a:latin typeface="Malgun Gothic" pitchFamily="34" charset="0"/>
+                <a:ea typeface="Malgun Gothic" pitchFamily="34" charset="-122"/>
+                <a:cs typeface="Malgun Gothic" pitchFamily="34" charset="-120"/>
+              </a:rPr>
+              <a:t>🚨  이상신호 감지  →  사회복지사에게 알림 전송</a:t>
+            </a:r>
+            <a:endParaRPr lang="en-US" sz="1300" dirty="0"/>
+          </a:p>
+        </p:txBody>
+      </p:sp>
+      <p:sp>
+        <p:nvSpPr>
+          <p:cNvPr id="16" name="Text 14"/>
+          <p:cNvSpPr txBox="1"/>
+          <p:nvPr/>
+        </p:nvSpPr>
+        <p:spPr>
+          <a:xfrm>
+            <a:off x="7744968" y="1572768"/>
+            <a:ext cx="3898087" cy="365760"/>
+          </a:xfrm>
+          <a:prstGeom prst="rect">
+            <a:avLst/>
+          </a:prstGeom>
+          <a:noFill/>
+          <a:ln/>
+        </p:spPr>
+        <p:txBody>
+          <a:bodyPr wrap="square" lIns="0" tIns="0" rIns="0" bIns="0" rtlCol="0" anchor="ctr"/>
+          <a:lstStyle/>
+          <a:p>
+            <a:pPr indent="0" marL="0">
+              <a:buNone/>
+            </a:pPr>
+            <a:r>
+              <a:rPr lang="en-US" sz="1600" b="1" dirty="0">
+                <a:solidFill>
+                  <a:srgbClr val="0F2F6F"/>
+                </a:solidFill>
+                <a:latin typeface="Malgun Gothic" pitchFamily="34" charset="0"/>
+                <a:ea typeface="Malgun Gothic" pitchFamily="34" charset="-122"/>
+                <a:cs typeface="Malgun Gothic" pitchFamily="34" charset="-120"/>
+              </a:rPr>
+              <a:t>AI가 답하는 방식</a:t>
+            </a:r>
+            <a:endParaRPr lang="en-US" sz="1600" dirty="0"/>
+          </a:p>
+        </p:txBody>
+      </p:sp>
+      <p:sp>
+        <p:nvSpPr>
+          <p:cNvPr id="17" name="Text 15"/>
+          <p:cNvSpPr txBox="1"/>
+          <p:nvPr/>
+        </p:nvSpPr>
+        <p:spPr>
+          <a:xfrm>
+            <a:off x="7744968" y="2048256"/>
+            <a:ext cx="3898087" cy="457200"/>
+          </a:xfrm>
+          <a:prstGeom prst="rect">
+            <a:avLst/>
+          </a:prstGeom>
+          <a:noFill/>
+          <a:ln/>
+        </p:spPr>
+        <p:txBody>
+          <a:bodyPr wrap="square" lIns="0" tIns="0" rIns="0" bIns="0" rtlCol="0" anchor="ctr"/>
+          <a:lstStyle/>
+          <a:p>
+            <a:pPr indent="0" marL="0">
+              <a:buNone/>
+            </a:pPr>
+            <a:r>
+              <a:rPr lang="en-US" sz="1400" b="1" dirty="0">
+                <a:solidFill>
+                  <a:srgbClr val="2E7D46"/>
+                </a:solidFill>
+                <a:latin typeface="Malgun Gothic" pitchFamily="34" charset="0"/>
+                <a:ea typeface="Malgun Gothic" pitchFamily="34" charset="-122"/>
+                <a:cs typeface="Malgun Gothic" pitchFamily="34" charset="-120"/>
+              </a:rPr>
+              <a:t>✓  </a:t>
+            </a:r>
+            <a:pPr indent="0" marL="0">
+              <a:buNone/>
+            </a:pPr>
+            <a:r>
+              <a:rPr lang="en-US" sz="1300" dirty="0">
+                <a:solidFill>
+                  <a:srgbClr val="1F2933"/>
+                </a:solidFill>
+                <a:latin typeface="Malgun Gothic" pitchFamily="34" charset="0"/>
+                <a:ea typeface="Malgun Gothic" pitchFamily="34" charset="-122"/>
+                <a:cs typeface="Malgun Gothic" pitchFamily="34" charset="-120"/>
+              </a:rPr>
+              <a:t>문서 근거로만 정확히 답변</a:t>
+            </a:r>
+            <a:endParaRPr lang="en-US" sz="1400" dirty="0"/>
+          </a:p>
+        </p:txBody>
+      </p:sp>
+      <p:sp>
+        <p:nvSpPr>
+          <p:cNvPr id="18" name="Text 16"/>
+          <p:cNvSpPr txBox="1"/>
+          <p:nvPr/>
+        </p:nvSpPr>
+        <p:spPr>
+          <a:xfrm>
+            <a:off x="7744968" y="2596896"/>
+            <a:ext cx="3898087" cy="457200"/>
+          </a:xfrm>
+          <a:prstGeom prst="rect">
+            <a:avLst/>
+          </a:prstGeom>
+          <a:noFill/>
+          <a:ln/>
+        </p:spPr>
+        <p:txBody>
+          <a:bodyPr wrap="square" lIns="0" tIns="0" rIns="0" bIns="0" rtlCol="0" anchor="ctr"/>
+          <a:lstStyle/>
+          <a:p>
+            <a:pPr indent="0" marL="0">
+              <a:buNone/>
+            </a:pPr>
+            <a:r>
+              <a:rPr lang="en-US" sz="1400" b="1" dirty="0">
+                <a:solidFill>
+                  <a:srgbClr val="2E7D46"/>
+                </a:solidFill>
+                <a:latin typeface="Malgun Gothic" pitchFamily="34" charset="0"/>
+                <a:ea typeface="Malgun Gothic" pitchFamily="34" charset="-122"/>
+                <a:cs typeface="Malgun Gothic" pitchFamily="34" charset="-120"/>
+              </a:rPr>
+              <a:t>✓  </a:t>
+            </a:r>
+            <a:pPr indent="0" marL="0">
+              <a:buNone/>
+            </a:pPr>
+            <a:r>
+              <a:rPr lang="en-US" sz="1300" dirty="0">
+                <a:solidFill>
+                  <a:srgbClr val="1F2933"/>
+                </a:solidFill>
+                <a:latin typeface="Malgun Gothic" pitchFamily="34" charset="0"/>
+                <a:ea typeface="Malgun Gothic" pitchFamily="34" charset="-122"/>
+                <a:cs typeface="Malgun Gothic" pitchFamily="34" charset="-120"/>
+              </a:rPr>
+              <a:t>모르면 지어내지 않고 주민센터 안내</a:t>
+            </a:r>
+            <a:endParaRPr lang="en-US" sz="1400" dirty="0"/>
+          </a:p>
+        </p:txBody>
+      </p:sp>
+      <p:sp>
+        <p:nvSpPr>
+          <p:cNvPr id="19" name="Text 17"/>
+          <p:cNvSpPr txBox="1"/>
+          <p:nvPr/>
+        </p:nvSpPr>
+        <p:spPr>
+          <a:xfrm>
+            <a:off x="7744968" y="3145536"/>
+            <a:ext cx="3898087" cy="457200"/>
+          </a:xfrm>
+          <a:prstGeom prst="rect">
+            <a:avLst/>
+          </a:prstGeom>
+          <a:noFill/>
+          <a:ln/>
+        </p:spPr>
+        <p:txBody>
+          <a:bodyPr wrap="square" lIns="0" tIns="0" rIns="0" bIns="0" rtlCol="0" anchor="ctr"/>
+          <a:lstStyle/>
+          <a:p>
+            <a:pPr indent="0" marL="0">
+              <a:buNone/>
+            </a:pPr>
+            <a:r>
+              <a:rPr lang="en-US" sz="1400" b="1" dirty="0">
+                <a:solidFill>
+                  <a:srgbClr val="2E7D46"/>
+                </a:solidFill>
+                <a:latin typeface="Malgun Gothic" pitchFamily="34" charset="0"/>
+                <a:ea typeface="Malgun Gothic" pitchFamily="34" charset="-122"/>
+                <a:cs typeface="Malgun Gothic" pitchFamily="34" charset="-120"/>
+              </a:rPr>
+              <a:t>✓  </a:t>
+            </a:r>
+            <a:pPr indent="0" marL="0">
+              <a:buNone/>
+            </a:pPr>
+            <a:r>
+              <a:rPr lang="en-US" sz="1300" dirty="0">
+                <a:solidFill>
+                  <a:srgbClr val="1F2933"/>
+                </a:solidFill>
+                <a:latin typeface="Malgun Gothic" pitchFamily="34" charset="0"/>
+                <a:ea typeface="Malgun Gothic" pitchFamily="34" charset="-122"/>
+                <a:cs typeface="Malgun Gothic" pitchFamily="34" charset="-120"/>
+              </a:rPr>
+              <a:t>위험 신호는 자동 감지·알림</a:t>
+            </a:r>
+            <a:endParaRPr lang="en-US" sz="1400" dirty="0"/>
+          </a:p>
+        </p:txBody>
+      </p:sp>
+      <p:sp>
+        <p:nvSpPr>
+          <p:cNvPr id="20" name="Shape 18"/>
+          <p:cNvSpPr/>
+          <p:nvPr/>
+        </p:nvSpPr>
+        <p:spPr>
+          <a:xfrm>
+            <a:off x="7744968" y="3822192"/>
+            <a:ext cx="3898087" cy="640080"/>
+          </a:xfrm>
+          <a:prstGeom prst="roundRect">
+            <a:avLst>
+              <a:gd name="adj" fmla="val 12857"/>
             </a:avLst>
           </a:prstGeom>
           <a:solidFill>
@@ -10101,75 +10705,126 @@
       </p:sp>
       <p:sp>
         <p:nvSpPr>
-          <p:cNvPr id="5" name="Shape 3"/>
+          <p:cNvPr id="21" name="Text 19"/>
+          <p:cNvSpPr txBox="1"/>
+          <p:nvPr/>
+        </p:nvSpPr>
+        <p:spPr>
+          <a:xfrm>
+            <a:off x="7927848" y="3822192"/>
+            <a:ext cx="1554480" cy="640080"/>
+          </a:xfrm>
+          <a:prstGeom prst="rect">
+            <a:avLst/>
+          </a:prstGeom>
+          <a:noFill/>
+          <a:ln/>
+        </p:spPr>
+        <p:txBody>
+          <a:bodyPr wrap="square" lIns="0" tIns="0" rIns="0" bIns="0" rtlCol="0" anchor="ctr"/>
+          <a:lstStyle/>
+          <a:p>
+            <a:pPr indent="0" marL="0">
+              <a:buNone/>
+            </a:pPr>
+            <a:r>
+              <a:rPr lang="en-US" sz="2400" b="1" dirty="0">
+                <a:solidFill>
+                  <a:srgbClr val="0F2F6F"/>
+                </a:solidFill>
+                <a:latin typeface="Malgun Gothic" pitchFamily="34" charset="0"/>
+                <a:ea typeface="Malgun Gothic" pitchFamily="34" charset="-122"/>
+                <a:cs typeface="Malgun Gothic" pitchFamily="34" charset="-120"/>
+              </a:rPr>
+              <a:t>92%</a:t>
+            </a:r>
+            <a:endParaRPr lang="en-US" sz="2400" dirty="0"/>
+          </a:p>
+        </p:txBody>
+      </p:sp>
+      <p:sp>
+        <p:nvSpPr>
+          <p:cNvPr id="22" name="Text 20"/>
+          <p:cNvSpPr txBox="1"/>
+          <p:nvPr/>
+        </p:nvSpPr>
+        <p:spPr>
+          <a:xfrm>
+            <a:off x="9482328" y="3822192"/>
+            <a:ext cx="1977847" cy="640080"/>
+          </a:xfrm>
+          <a:prstGeom prst="rect">
+            <a:avLst/>
+          </a:prstGeom>
+          <a:noFill/>
+          <a:ln/>
+        </p:spPr>
+        <p:txBody>
+          <a:bodyPr wrap="square" lIns="0" tIns="0" rIns="0" bIns="0" rtlCol="0" anchor="ctr"/>
+          <a:lstStyle/>
+          <a:p>
+            <a:pPr indent="0" marL="0">
+              <a:buNone/>
+            </a:pPr>
+            <a:r>
+              <a:rPr lang="en-US" sz="1300" b="1" dirty="0">
+                <a:solidFill>
+                  <a:srgbClr val="1F2933"/>
+                </a:solidFill>
+                <a:latin typeface="Malgun Gothic" pitchFamily="34" charset="0"/>
+                <a:ea typeface="Malgun Gothic" pitchFamily="34" charset="-122"/>
+                <a:cs typeface="Malgun Gothic" pitchFamily="34" charset="-120"/>
+              </a:rPr>
+              <a:t>정답률</a:t>
+            </a:r>
+            <a:endParaRPr lang="en-US" sz="1300" dirty="0"/>
+          </a:p>
+        </p:txBody>
+      </p:sp>
+      <p:sp>
+        <p:nvSpPr>
+          <p:cNvPr id="23" name="Shape 21"/>
           <p:cNvSpPr/>
           <p:nvPr/>
         </p:nvSpPr>
         <p:spPr>
           <a:xfrm>
-            <a:off x="822960" y="1810512"/>
-            <a:ext cx="1371600" cy="365760"/>
+            <a:off x="7744968" y="4572000"/>
+            <a:ext cx="3898087" cy="640080"/>
           </a:xfrm>
           <a:prstGeom prst="roundRect">
             <a:avLst>
-              <a:gd name="adj" fmla="val 15000"/>
+              <a:gd name="adj" fmla="val 12857"/>
             </a:avLst>
           </a:prstGeom>
           <a:solidFill>
-            <a:srgbClr val="0F2F6F"/>
+            <a:srgbClr val="F4F7FC"/>
           </a:solidFill>
-          <a:ln/>
-        </p:spPr>
-      </p:sp>
-      <p:sp>
-        <p:nvSpPr>
-          <p:cNvPr id="6" name="Text 4"/>
-          <p:cNvSpPr txBox="1"/>
-          <p:nvPr/>
-        </p:nvSpPr>
-        <p:spPr>
-          <a:xfrm>
-            <a:off x="822960" y="1810512"/>
-            <a:ext cx="1371600" cy="365760"/>
-          </a:xfrm>
-          <a:prstGeom prst="rect">
-            <a:avLst/>
-          </a:prstGeom>
-          <a:noFill/>
-          <a:ln/>
-        </p:spPr>
-        <p:txBody>
-          <a:bodyPr wrap="square" lIns="0" tIns="0" rIns="0" bIns="0" rtlCol="0" anchor="ctr"/>
-          <a:lstStyle/>
-          <a:p>
-            <a:pPr algn="ctr" indent="0" marL="0">
-              <a:buNone/>
-            </a:pPr>
-            <a:r>
-              <a:rPr lang="en-US" sz="1200" b="1" dirty="0">
-                <a:solidFill>
-                  <a:srgbClr val="FFFFFF"/>
-                </a:solidFill>
-                <a:latin typeface="Malgun Gothic" pitchFamily="34" charset="0"/>
-                <a:ea typeface="Malgun Gothic" pitchFamily="34" charset="-122"/>
-                <a:cs typeface="Malgun Gothic" pitchFamily="34" charset="-120"/>
-              </a:rPr>
-              <a:t>데모 A</a:t>
-            </a:r>
-            <a:endParaRPr lang="en-US" sz="1200" dirty="0"/>
-          </a:p>
-        </p:txBody>
-      </p:sp>
-      <p:sp>
-        <p:nvSpPr>
-          <p:cNvPr id="7" name="Text 5"/>
-          <p:cNvSpPr txBox="1"/>
-          <p:nvPr/>
-        </p:nvSpPr>
-        <p:spPr>
-          <a:xfrm>
-            <a:off x="2331720" y="1810512"/>
-            <a:ext cx="3352648" cy="365760"/>
+          <a:ln w="12700">
+            <a:solidFill>
+              <a:srgbClr val="D8E0EC"/>
+            </a:solidFill>
+            <a:prstDash val="solid"/>
+          </a:ln>
+          <a:effectLst>
+            <a:outerShdw sx="100000" sy="100000" kx="0" ky="0" algn="bl" rotWithShape="0" blurRad="76200" dist="25400" dir="5400000">
+              <a:srgbClr val="9AA5B5">
+                <a:alpha val="35000"/>
+              </a:srgbClr>
+            </a:outerShdw>
+          </a:effectLst>
+        </p:spPr>
+      </p:sp>
+      <p:sp>
+        <p:nvSpPr>
+          <p:cNvPr id="24" name="Text 22"/>
+          <p:cNvSpPr txBox="1"/>
+          <p:nvPr/>
+        </p:nvSpPr>
+        <p:spPr>
+          <a:xfrm>
+            <a:off x="7927848" y="4572000"/>
+            <a:ext cx="1554480" cy="640080"/>
           </a:xfrm>
           <a:prstGeom prst="rect">
             <a:avLst/>
@@ -10185,7 +10840,7 @@
               <a:buNone/>
             </a:pPr>
             <a:r>
-              <a:rPr lang="en-US" sz="1600" b="1" dirty="0">
+              <a:rPr lang="en-US" sz="2400" b="1" dirty="0">
                 <a:solidFill>
                   <a:srgbClr val="0F2F6F"/>
                 </a:solidFill>
@@ -10193,42 +10848,38 @@
                 <a:ea typeface="Malgun Gothic" pitchFamily="34" charset="-122"/>
                 <a:cs typeface="Malgun Gothic" pitchFamily="34" charset="-120"/>
               </a:rPr>
-              <a:t>복지 Q&amp;A</a:t>
-            </a:r>
-            <a:endParaRPr lang="en-US" sz="1600" dirty="0"/>
-          </a:p>
-        </p:txBody>
-      </p:sp>
-      <p:sp>
-        <p:nvSpPr>
-          <p:cNvPr id="8" name="Text 6"/>
-          <p:cNvSpPr txBox="1"/>
-          <p:nvPr/>
-        </p:nvSpPr>
-        <p:spPr>
-          <a:xfrm>
-            <a:off x="822960" y="2286000"/>
-            <a:ext cx="4815688" cy="1371600"/>
-          </a:xfrm>
-          <a:prstGeom prst="rect">
-            <a:avLst/>
-          </a:prstGeom>
-          <a:noFill/>
-          <a:ln/>
-        </p:spPr>
-        <p:txBody>
-          <a:bodyPr wrap="square" rtlCol="0" anchor="t"/>
-          <a:lstStyle/>
-          <a:p>
-            <a:pPr marL="342900" indent="-342900">
-              <a:spcAft>
-                <a:spcPts val="600"/>
-              </a:spcAft>
-              <a:buSzPct val="100000"/>
-              <a:buChar char="•"/>
-            </a:pPr>
-            <a:r>
-              <a:rPr lang="en-US" sz="1300" dirty="0">
+              <a:t>100%</a:t>
+            </a:r>
+            <a:endParaRPr lang="en-US" sz="2400" dirty="0"/>
+          </a:p>
+        </p:txBody>
+      </p:sp>
+      <p:sp>
+        <p:nvSpPr>
+          <p:cNvPr id="25" name="Text 23"/>
+          <p:cNvSpPr txBox="1"/>
+          <p:nvPr/>
+        </p:nvSpPr>
+        <p:spPr>
+          <a:xfrm>
+            <a:off x="9482328" y="4572000"/>
+            <a:ext cx="1977847" cy="640080"/>
+          </a:xfrm>
+          <a:prstGeom prst="rect">
+            <a:avLst/>
+          </a:prstGeom>
+          <a:noFill/>
+          <a:ln/>
+        </p:spPr>
+        <p:txBody>
+          <a:bodyPr wrap="square" lIns="0" tIns="0" rIns="0" bIns="0" rtlCol="0" anchor="ctr"/>
+          <a:lstStyle/>
+          <a:p>
+            <a:pPr indent="0" marL="0">
+              <a:buNone/>
+            </a:pPr>
+            <a:r>
+              <a:rPr lang="en-US" sz="1300" b="1" dirty="0">
                 <a:solidFill>
                   <a:srgbClr val="1F2933"/>
                 </a:solidFill>
@@ -10236,68 +10887,26 @@
                 <a:ea typeface="Malgun Gothic" pitchFamily="34" charset="-122"/>
                 <a:cs typeface="Malgun Gothic" pitchFamily="34" charset="-120"/>
               </a:rPr>
-              <a:t>"기초연금은 어떻게 신청하나요?" → 문서 근거 기반 정확 안내</a:t>
+              <a:t>범위 밖 거절</a:t>
             </a:r>
             <a:endParaRPr lang="en-US" sz="1300" dirty="0"/>
           </a:p>
-          <a:p>
-            <a:pPr marL="342900" indent="-342900">
-              <a:spcAft>
-                <a:spcPts val="600"/>
-              </a:spcAft>
-              <a:buSzPct val="100000"/>
-              <a:buChar char="•"/>
-            </a:pPr>
-            <a:r>
-              <a:rPr lang="en-US" sz="1300" dirty="0">
-                <a:solidFill>
-                  <a:srgbClr val="1F2933"/>
-                </a:solidFill>
-                <a:latin typeface="Malgun Gothic" pitchFamily="34" charset="0"/>
-                <a:ea typeface="Malgun Gothic" pitchFamily="34" charset="-122"/>
-                <a:cs typeface="Malgun Gothic" pitchFamily="34" charset="-120"/>
-              </a:rPr>
-              <a:t>범위 밖 질문은 지어내지 않고 안전하게 거절</a:t>
-            </a:r>
-            <a:endParaRPr lang="en-US" sz="1300" dirty="0"/>
-          </a:p>
-          <a:p>
-            <a:pPr marL="342900" indent="-342900">
-              <a:spcAft>
-                <a:spcPts val="600"/>
-              </a:spcAft>
-              <a:buSzPct val="100000"/>
-              <a:buChar char="•"/>
-            </a:pPr>
-            <a:r>
-              <a:rPr lang="en-US" sz="1300" dirty="0">
-                <a:solidFill>
-                  <a:srgbClr val="1F2933"/>
-                </a:solidFill>
-                <a:latin typeface="Malgun Gothic" pitchFamily="34" charset="0"/>
-                <a:ea typeface="Malgun Gothic" pitchFamily="34" charset="-122"/>
-                <a:cs typeface="Malgun Gothic" pitchFamily="34" charset="-120"/>
-              </a:rPr>
-              <a:t>인사·잡담은 따뜻한 대화형 응답</a:t>
-            </a:r>
-            <a:endParaRPr lang="en-US" sz="1300" dirty="0"/>
-          </a:p>
-        </p:txBody>
-      </p:sp>
-      <p:sp>
-        <p:nvSpPr>
-          <p:cNvPr id="9" name="Shape 7"/>
+        </p:txBody>
+      </p:sp>
+      <p:sp>
+        <p:nvSpPr>
+          <p:cNvPr id="26" name="Shape 24"/>
           <p:cNvSpPr/>
           <p:nvPr/>
         </p:nvSpPr>
         <p:spPr>
           <a:xfrm>
-            <a:off x="6278728" y="1600200"/>
-            <a:ext cx="5364328" cy="2148840"/>
+            <a:off x="7744968" y="5321808"/>
+            <a:ext cx="3898087" cy="640080"/>
           </a:xfrm>
           <a:prstGeom prst="roundRect">
             <a:avLst>
-              <a:gd name="adj" fmla="val 3830"/>
+              <a:gd name="adj" fmla="val 12857"/>
             </a:avLst>
           </a:prstGeom>
           <a:solidFill>
@@ -10320,75 +10929,14 @@
       </p:sp>
       <p:sp>
         <p:nvSpPr>
-          <p:cNvPr id="10" name="Shape 8"/>
-          <p:cNvSpPr/>
-          <p:nvPr/>
-        </p:nvSpPr>
-        <p:spPr>
-          <a:xfrm>
-            <a:off x="6553048" y="1810512"/>
-            <a:ext cx="1371600" cy="365760"/>
-          </a:xfrm>
-          <a:prstGeom prst="roundRect">
-            <a:avLst>
-              <a:gd name="adj" fmla="val 15000"/>
-            </a:avLst>
-          </a:prstGeom>
-          <a:solidFill>
-            <a:srgbClr val="E0A83C"/>
-          </a:solidFill>
-          <a:ln/>
-        </p:spPr>
-      </p:sp>
-      <p:sp>
-        <p:nvSpPr>
-          <p:cNvPr id="11" name="Text 9"/>
-          <p:cNvSpPr txBox="1"/>
-          <p:nvPr/>
-        </p:nvSpPr>
-        <p:spPr>
-          <a:xfrm>
-            <a:off x="6553048" y="1810512"/>
-            <a:ext cx="1371600" cy="365760"/>
-          </a:xfrm>
-          <a:prstGeom prst="rect">
-            <a:avLst/>
-          </a:prstGeom>
-          <a:noFill/>
-          <a:ln/>
-        </p:spPr>
-        <p:txBody>
-          <a:bodyPr wrap="square" lIns="0" tIns="0" rIns="0" bIns="0" rtlCol="0" anchor="ctr"/>
-          <a:lstStyle/>
-          <a:p>
-            <a:pPr algn="ctr" indent="0" marL="0">
-              <a:buNone/>
-            </a:pPr>
-            <a:r>
-              <a:rPr lang="en-US" sz="1200" b="1" dirty="0">
-                <a:solidFill>
-                  <a:srgbClr val="FFFFFF"/>
-                </a:solidFill>
-                <a:latin typeface="Malgun Gothic" pitchFamily="34" charset="0"/>
-                <a:ea typeface="Malgun Gothic" pitchFamily="34" charset="-122"/>
-                <a:cs typeface="Malgun Gothic" pitchFamily="34" charset="-120"/>
-              </a:rPr>
-              <a:t>데모 B</a:t>
-            </a:r>
-            <a:endParaRPr lang="en-US" sz="1200" dirty="0"/>
-          </a:p>
-        </p:txBody>
-      </p:sp>
-      <p:sp>
-        <p:nvSpPr>
-          <p:cNvPr id="12" name="Text 10"/>
-          <p:cNvSpPr txBox="1"/>
-          <p:nvPr/>
-        </p:nvSpPr>
-        <p:spPr>
-          <a:xfrm>
-            <a:off x="8061808" y="1810512"/>
-            <a:ext cx="3352648" cy="365760"/>
+          <p:cNvPr id="27" name="Text 25"/>
+          <p:cNvSpPr txBox="1"/>
+          <p:nvPr/>
+        </p:nvSpPr>
+        <p:spPr>
+          <a:xfrm>
+            <a:off x="7927848" y="5321808"/>
+            <a:ext cx="1554480" cy="640080"/>
           </a:xfrm>
           <a:prstGeom prst="rect">
             <a:avLst/>
@@ -10404,7 +10952,7 @@
               <a:buNone/>
             </a:pPr>
             <a:r>
-              <a:rPr lang="en-US" sz="1600" b="1" dirty="0">
+              <a:rPr lang="en-US" sz="2400" b="1" dirty="0">
                 <a:solidFill>
                   <a:srgbClr val="B8862B"/>
                 </a:solidFill>
@@ -10412,42 +10960,38 @@
                 <a:ea typeface="Malgun Gothic" pitchFamily="34" charset="-122"/>
                 <a:cs typeface="Malgun Gothic" pitchFamily="34" charset="-120"/>
               </a:rPr>
-              <a:t>이상신호 감지</a:t>
-            </a:r>
-            <a:endParaRPr lang="en-US" sz="1600" dirty="0"/>
-          </a:p>
-        </p:txBody>
-      </p:sp>
-      <p:sp>
-        <p:nvSpPr>
-          <p:cNvPr id="13" name="Text 11"/>
-          <p:cNvSpPr txBox="1"/>
-          <p:nvPr/>
-        </p:nvSpPr>
-        <p:spPr>
-          <a:xfrm>
-            <a:off x="6553048" y="2286000"/>
-            <a:ext cx="4815688" cy="1371600"/>
-          </a:xfrm>
-          <a:prstGeom prst="rect">
-            <a:avLst/>
-          </a:prstGeom>
-          <a:noFill/>
-          <a:ln/>
-        </p:spPr>
-        <p:txBody>
-          <a:bodyPr wrap="square" rtlCol="0" anchor="t"/>
-          <a:lstStyle/>
-          <a:p>
-            <a:pPr marL="342900" indent="-342900">
-              <a:spcAft>
-                <a:spcPts val="600"/>
-              </a:spcAft>
-              <a:buSzPct val="100000"/>
-              <a:buChar char="•"/>
-            </a:pPr>
-            <a:r>
-              <a:rPr lang="en-US" sz="1300" dirty="0">
+              <a:t>+14%p</a:t>
+            </a:r>
+            <a:endParaRPr lang="en-US" sz="2400" dirty="0"/>
+          </a:p>
+        </p:txBody>
+      </p:sp>
+      <p:sp>
+        <p:nvSpPr>
+          <p:cNvPr id="28" name="Text 26"/>
+          <p:cNvSpPr txBox="1"/>
+          <p:nvPr/>
+        </p:nvSpPr>
+        <p:spPr>
+          <a:xfrm>
+            <a:off x="9482328" y="5321808"/>
+            <a:ext cx="1977847" cy="640080"/>
+          </a:xfrm>
+          <a:prstGeom prst="rect">
+            <a:avLst/>
+          </a:prstGeom>
+          <a:noFill/>
+          <a:ln/>
+        </p:spPr>
+        <p:txBody>
+          <a:bodyPr wrap="square" lIns="0" tIns="0" rIns="0" bIns="0" rtlCol="0" anchor="ctr"/>
+          <a:lstStyle/>
+          <a:p>
+            <a:pPr indent="0" marL="0">
+              <a:buNone/>
+            </a:pPr>
+            <a:r>
+              <a:rPr lang="en-US" sz="1300" b="1" dirty="0">
                 <a:solidFill>
                   <a:srgbClr val="1F2933"/>
                 </a:solidFill>
@@ -10455,504 +10999,9 @@
                 <a:ea typeface="Malgun Gothic" pitchFamily="34" charset="-122"/>
                 <a:cs typeface="Malgun Gothic" pitchFamily="34" charset="-120"/>
               </a:rPr>
-              <a:t>증상 반복 + 부정 감정 대화 감지</a:t>
+              <a:t>재랭킹 효과</a:t>
             </a:r>
             <a:endParaRPr lang="en-US" sz="1300" dirty="0"/>
-          </a:p>
-          <a:p>
-            <a:pPr marL="342900" indent="-342900">
-              <a:spcAft>
-                <a:spcPts val="600"/>
-              </a:spcAft>
-              <a:buSzPct val="100000"/>
-              <a:buChar char="•"/>
-            </a:pPr>
-            <a:r>
-              <a:rPr lang="en-US" sz="1300" dirty="0">
-                <a:solidFill>
-                  <a:srgbClr val="1F2933"/>
-                </a:solidFill>
-                <a:latin typeface="Malgun Gothic" pitchFamily="34" charset="0"/>
-                <a:ea typeface="Malgun Gothic" pitchFamily="34" charset="-122"/>
-                <a:cs typeface="Malgun Gothic" pitchFamily="34" charset="-120"/>
-              </a:rPr>
-              <a:t>위기 키워드 시 즉시 긴급 알림</a:t>
-            </a:r>
-            <a:endParaRPr lang="en-US" sz="1300" dirty="0"/>
-          </a:p>
-          <a:p>
-            <a:pPr marL="342900" indent="-342900">
-              <a:spcAft>
-                <a:spcPts val="600"/>
-              </a:spcAft>
-              <a:buSzPct val="100000"/>
-              <a:buChar char="•"/>
-            </a:pPr>
-            <a:r>
-              <a:rPr lang="en-US" sz="1300" dirty="0">
-                <a:solidFill>
-                  <a:srgbClr val="1F2933"/>
-                </a:solidFill>
-                <a:latin typeface="Malgun Gothic" pitchFamily="34" charset="0"/>
-                <a:ea typeface="Malgun Gothic" pitchFamily="34" charset="-122"/>
-                <a:cs typeface="Malgun Gothic" pitchFamily="34" charset="-120"/>
-              </a:rPr>
-              <a:t>→ 사회복지사 알림 요약 생성</a:t>
-            </a:r>
-            <a:endParaRPr lang="en-US" sz="1300" dirty="0"/>
-          </a:p>
-        </p:txBody>
-      </p:sp>
-      <p:sp>
-        <p:nvSpPr>
-          <p:cNvPr id="14" name="Shape 12"/>
-          <p:cNvSpPr/>
-          <p:nvPr/>
-        </p:nvSpPr>
-        <p:spPr>
-          <a:xfrm>
-            <a:off x="548640" y="3977640"/>
-            <a:ext cx="3454298" cy="1783080"/>
-          </a:xfrm>
-          <a:prstGeom prst="roundRect">
-            <a:avLst>
-              <a:gd name="adj" fmla="val 4615"/>
-            </a:avLst>
-          </a:prstGeom>
-          <a:solidFill>
-            <a:srgbClr val="FFFFFF"/>
-          </a:solidFill>
-          <a:ln w="12700">
-            <a:solidFill>
-              <a:srgbClr val="D8E0EC"/>
-            </a:solidFill>
-            <a:prstDash val="solid"/>
-          </a:ln>
-          <a:effectLst>
-            <a:outerShdw sx="100000" sy="100000" kx="0" ky="0" algn="bl" rotWithShape="0" blurRad="76200" dist="25400" dir="5400000">
-              <a:srgbClr val="9AA5B5">
-                <a:alpha val="35000"/>
-              </a:srgbClr>
-            </a:outerShdw>
-          </a:effectLst>
-        </p:spPr>
-      </p:sp>
-      <p:sp>
-        <p:nvSpPr>
-          <p:cNvPr id="15" name="Text 13"/>
-          <p:cNvSpPr txBox="1"/>
-          <p:nvPr/>
-        </p:nvSpPr>
-        <p:spPr>
-          <a:xfrm>
-            <a:off x="731520" y="4160520"/>
-            <a:ext cx="3088538" cy="731520"/>
-          </a:xfrm>
-          <a:prstGeom prst="rect">
-            <a:avLst/>
-          </a:prstGeom>
-          <a:noFill/>
-          <a:ln/>
-        </p:spPr>
-        <p:txBody>
-          <a:bodyPr wrap="square" lIns="0" tIns="0" rIns="0" bIns="0" rtlCol="0" anchor="ctr"/>
-          <a:lstStyle/>
-          <a:p>
-            <a:pPr indent="0" marL="0">
-              <a:buNone/>
-            </a:pPr>
-            <a:r>
-              <a:rPr lang="en-US" sz="3600" b="1" dirty="0">
-                <a:solidFill>
-                  <a:srgbClr val="0F2F6F"/>
-                </a:solidFill>
-                <a:latin typeface="Malgun Gothic" pitchFamily="34" charset="0"/>
-                <a:ea typeface="Malgun Gothic" pitchFamily="34" charset="-122"/>
-                <a:cs typeface="Malgun Gothic" pitchFamily="34" charset="-120"/>
-              </a:rPr>
-              <a:t>3,455개</a:t>
-            </a:r>
-            <a:endParaRPr lang="en-US" sz="3600" dirty="0"/>
-          </a:p>
-        </p:txBody>
-      </p:sp>
-      <p:sp>
-        <p:nvSpPr>
-          <p:cNvPr id="16" name="Text 14"/>
-          <p:cNvSpPr txBox="1"/>
-          <p:nvPr/>
-        </p:nvSpPr>
-        <p:spPr>
-          <a:xfrm>
-            <a:off x="731520" y="4919472"/>
-            <a:ext cx="3088538" cy="320040"/>
-          </a:xfrm>
-          <a:prstGeom prst="rect">
-            <a:avLst/>
-          </a:prstGeom>
-          <a:noFill/>
-          <a:ln/>
-        </p:spPr>
-        <p:txBody>
-          <a:bodyPr wrap="square" lIns="0" tIns="0" rIns="0" bIns="0" rtlCol="0" anchor="ctr"/>
-          <a:lstStyle/>
-          <a:p>
-            <a:pPr indent="0" marL="0">
-              <a:buNone/>
-            </a:pPr>
-            <a:r>
-              <a:rPr lang="en-US" sz="1400" b="1" dirty="0">
-                <a:solidFill>
-                  <a:srgbClr val="1F2933"/>
-                </a:solidFill>
-                <a:latin typeface="Malgun Gothic" pitchFamily="34" charset="0"/>
-                <a:ea typeface="Malgun Gothic" pitchFamily="34" charset="-122"/>
-                <a:cs typeface="Malgun Gothic" pitchFamily="34" charset="-120"/>
-              </a:rPr>
-              <a:t>색인 청크</a:t>
-            </a:r>
-            <a:endParaRPr lang="en-US" sz="1400" dirty="0"/>
-          </a:p>
-        </p:txBody>
-      </p:sp>
-      <p:sp>
-        <p:nvSpPr>
-          <p:cNvPr id="17" name="Text 15"/>
-          <p:cNvSpPr txBox="1"/>
-          <p:nvPr/>
-        </p:nvSpPr>
-        <p:spPr>
-          <a:xfrm>
-            <a:off x="731520" y="5230368"/>
-            <a:ext cx="3088538" cy="457200"/>
-          </a:xfrm>
-          <a:prstGeom prst="rect">
-            <a:avLst/>
-          </a:prstGeom>
-          <a:noFill/>
-          <a:ln/>
-        </p:spPr>
-        <p:txBody>
-          <a:bodyPr wrap="square" lIns="0" tIns="0" rIns="0" bIns="0" rtlCol="0" anchor="ctr"/>
-          <a:lstStyle/>
-          <a:p>
-            <a:pPr indent="0" marL="0">
-              <a:buNone/>
-            </a:pPr>
-            <a:r>
-              <a:rPr lang="en-US" sz="1100" dirty="0">
-                <a:solidFill>
-                  <a:srgbClr val="5B6673"/>
-                </a:solidFill>
-                <a:latin typeface="Malgun Gothic" pitchFamily="34" charset="0"/>
-                <a:ea typeface="Malgun Gothic" pitchFamily="34" charset="-122"/>
-                <a:cs typeface="Malgun Gothic" pitchFamily="34" charset="-120"/>
-              </a:rPr>
-              <a:t>보건복지부 사업안내 + 대전 공개데이터</a:t>
-            </a:r>
-            <a:endParaRPr lang="en-US" sz="1100" dirty="0"/>
-          </a:p>
-        </p:txBody>
-      </p:sp>
-      <p:sp>
-        <p:nvSpPr>
-          <p:cNvPr id="18" name="Shape 16"/>
-          <p:cNvSpPr/>
-          <p:nvPr/>
-        </p:nvSpPr>
-        <p:spPr>
-          <a:xfrm>
-            <a:off x="4368698" y="3977640"/>
-            <a:ext cx="3454298" cy="1783080"/>
-          </a:xfrm>
-          <a:prstGeom prst="roundRect">
-            <a:avLst>
-              <a:gd name="adj" fmla="val 4615"/>
-            </a:avLst>
-          </a:prstGeom>
-          <a:solidFill>
-            <a:srgbClr val="FFFFFF"/>
-          </a:solidFill>
-          <a:ln w="12700">
-            <a:solidFill>
-              <a:srgbClr val="D8E0EC"/>
-            </a:solidFill>
-            <a:prstDash val="solid"/>
-          </a:ln>
-          <a:effectLst>
-            <a:outerShdw sx="100000" sy="100000" kx="0" ky="0" algn="bl" rotWithShape="0" blurRad="76200" dist="25400" dir="5400000">
-              <a:srgbClr val="9AA5B5">
-                <a:alpha val="35000"/>
-              </a:srgbClr>
-            </a:outerShdw>
-          </a:effectLst>
-        </p:spPr>
-      </p:sp>
-      <p:sp>
-        <p:nvSpPr>
-          <p:cNvPr id="19" name="Text 17"/>
-          <p:cNvSpPr txBox="1"/>
-          <p:nvPr/>
-        </p:nvSpPr>
-        <p:spPr>
-          <a:xfrm>
-            <a:off x="4551578" y="4160520"/>
-            <a:ext cx="3088538" cy="731520"/>
-          </a:xfrm>
-          <a:prstGeom prst="rect">
-            <a:avLst/>
-          </a:prstGeom>
-          <a:noFill/>
-          <a:ln/>
-        </p:spPr>
-        <p:txBody>
-          <a:bodyPr wrap="square" lIns="0" tIns="0" rIns="0" bIns="0" rtlCol="0" anchor="ctr"/>
-          <a:lstStyle/>
-          <a:p>
-            <a:pPr indent="0" marL="0">
-              <a:buNone/>
-            </a:pPr>
-            <a:r>
-              <a:rPr lang="en-US" sz="3600" b="1" dirty="0">
-                <a:solidFill>
-                  <a:srgbClr val="0F2F6F"/>
-                </a:solidFill>
-                <a:latin typeface="Malgun Gothic" pitchFamily="34" charset="0"/>
-                <a:ea typeface="Malgun Gothic" pitchFamily="34" charset="-122"/>
-                <a:cs typeface="Malgun Gothic" pitchFamily="34" charset="-120"/>
-              </a:rPr>
-              <a:t>92%</a:t>
-            </a:r>
-            <a:endParaRPr lang="en-US" sz="3600" dirty="0"/>
-          </a:p>
-        </p:txBody>
-      </p:sp>
-      <p:sp>
-        <p:nvSpPr>
-          <p:cNvPr id="20" name="Text 18"/>
-          <p:cNvSpPr txBox="1"/>
-          <p:nvPr/>
-        </p:nvSpPr>
-        <p:spPr>
-          <a:xfrm>
-            <a:off x="4551578" y="4919472"/>
-            <a:ext cx="3088538" cy="320040"/>
-          </a:xfrm>
-          <a:prstGeom prst="rect">
-            <a:avLst/>
-          </a:prstGeom>
-          <a:noFill/>
-          <a:ln/>
-        </p:spPr>
-        <p:txBody>
-          <a:bodyPr wrap="square" lIns="0" tIns="0" rIns="0" bIns="0" rtlCol="0" anchor="ctr"/>
-          <a:lstStyle/>
-          <a:p>
-            <a:pPr indent="0" marL="0">
-              <a:buNone/>
-            </a:pPr>
-            <a:r>
-              <a:rPr lang="en-US" sz="1400" b="1" dirty="0">
-                <a:solidFill>
-                  <a:srgbClr val="1F2933"/>
-                </a:solidFill>
-                <a:latin typeface="Malgun Gothic" pitchFamily="34" charset="0"/>
-                <a:ea typeface="Malgun Gothic" pitchFamily="34" charset="-122"/>
-                <a:cs typeface="Malgun Gothic" pitchFamily="34" charset="-120"/>
-              </a:rPr>
-              <a:t>200문항 정답률</a:t>
-            </a:r>
-            <a:endParaRPr lang="en-US" sz="1400" dirty="0"/>
-          </a:p>
-        </p:txBody>
-      </p:sp>
-      <p:sp>
-        <p:nvSpPr>
-          <p:cNvPr id="21" name="Text 19"/>
-          <p:cNvSpPr txBox="1"/>
-          <p:nvPr/>
-        </p:nvSpPr>
-        <p:spPr>
-          <a:xfrm>
-            <a:off x="4551578" y="5230368"/>
-            <a:ext cx="3088538" cy="457200"/>
-          </a:xfrm>
-          <a:prstGeom prst="rect">
-            <a:avLst/>
-          </a:prstGeom>
-          <a:noFill/>
-          <a:ln/>
-        </p:spPr>
-        <p:txBody>
-          <a:bodyPr wrap="square" lIns="0" tIns="0" rIns="0" bIns="0" rtlCol="0" anchor="ctr"/>
-          <a:lstStyle/>
-          <a:p>
-            <a:pPr indent="0" marL="0">
-              <a:buNone/>
-            </a:pPr>
-            <a:r>
-              <a:rPr lang="en-US" sz="1100" dirty="0">
-                <a:solidFill>
-                  <a:srgbClr val="5B6673"/>
-                </a:solidFill>
-                <a:latin typeface="Malgun Gothic" pitchFamily="34" charset="0"/>
-                <a:ea typeface="Malgun Gothic" pitchFamily="34" charset="-122"/>
-                <a:cs typeface="Malgun Gothic" pitchFamily="34" charset="-120"/>
-              </a:rPr>
-              <a:t>범위 밖 거절 100% · 사실정확도 98%</a:t>
-            </a:r>
-            <a:endParaRPr lang="en-US" sz="1100" dirty="0"/>
-          </a:p>
-        </p:txBody>
-      </p:sp>
-      <p:sp>
-        <p:nvSpPr>
-          <p:cNvPr id="22" name="Shape 20"/>
-          <p:cNvSpPr/>
-          <p:nvPr/>
-        </p:nvSpPr>
-        <p:spPr>
-          <a:xfrm>
-            <a:off x="8188757" y="3977640"/>
-            <a:ext cx="3454298" cy="1783080"/>
-          </a:xfrm>
-          <a:prstGeom prst="roundRect">
-            <a:avLst>
-              <a:gd name="adj" fmla="val 4615"/>
-            </a:avLst>
-          </a:prstGeom>
-          <a:solidFill>
-            <a:srgbClr val="FFFFFF"/>
-          </a:solidFill>
-          <a:ln w="12700">
-            <a:solidFill>
-              <a:srgbClr val="D8E0EC"/>
-            </a:solidFill>
-            <a:prstDash val="solid"/>
-          </a:ln>
-          <a:effectLst>
-            <a:outerShdw sx="100000" sy="100000" kx="0" ky="0" algn="bl" rotWithShape="0" blurRad="76200" dist="25400" dir="5400000">
-              <a:srgbClr val="9AA5B5">
-                <a:alpha val="35000"/>
-              </a:srgbClr>
-            </a:outerShdw>
-          </a:effectLst>
-        </p:spPr>
-      </p:sp>
-      <p:sp>
-        <p:nvSpPr>
-          <p:cNvPr id="23" name="Text 21"/>
-          <p:cNvSpPr txBox="1"/>
-          <p:nvPr/>
-        </p:nvSpPr>
-        <p:spPr>
-          <a:xfrm>
-            <a:off x="8371637" y="4160520"/>
-            <a:ext cx="3088538" cy="731520"/>
-          </a:xfrm>
-          <a:prstGeom prst="rect">
-            <a:avLst/>
-          </a:prstGeom>
-          <a:noFill/>
-          <a:ln/>
-        </p:spPr>
-        <p:txBody>
-          <a:bodyPr wrap="square" lIns="0" tIns="0" rIns="0" bIns="0" rtlCol="0" anchor="ctr"/>
-          <a:lstStyle/>
-          <a:p>
-            <a:pPr indent="0" marL="0">
-              <a:buNone/>
-            </a:pPr>
-            <a:r>
-              <a:rPr lang="en-US" sz="3600" b="1" dirty="0">
-                <a:solidFill>
-                  <a:srgbClr val="B8862B"/>
-                </a:solidFill>
-                <a:latin typeface="Malgun Gothic" pitchFamily="34" charset="0"/>
-                <a:ea typeface="Malgun Gothic" pitchFamily="34" charset="-122"/>
-                <a:cs typeface="Malgun Gothic" pitchFamily="34" charset="-120"/>
-              </a:rPr>
-              <a:t>+14%p</a:t>
-            </a:r>
-            <a:endParaRPr lang="en-US" sz="3600" dirty="0"/>
-          </a:p>
-        </p:txBody>
-      </p:sp>
-      <p:sp>
-        <p:nvSpPr>
-          <p:cNvPr id="24" name="Text 22"/>
-          <p:cNvSpPr txBox="1"/>
-          <p:nvPr/>
-        </p:nvSpPr>
-        <p:spPr>
-          <a:xfrm>
-            <a:off x="8371637" y="4919472"/>
-            <a:ext cx="3088538" cy="320040"/>
-          </a:xfrm>
-          <a:prstGeom prst="rect">
-            <a:avLst/>
-          </a:prstGeom>
-          <a:noFill/>
-          <a:ln/>
-        </p:spPr>
-        <p:txBody>
-          <a:bodyPr wrap="square" lIns="0" tIns="0" rIns="0" bIns="0" rtlCol="0" anchor="ctr"/>
-          <a:lstStyle/>
-          <a:p>
-            <a:pPr indent="0" marL="0">
-              <a:buNone/>
-            </a:pPr>
-            <a:r>
-              <a:rPr lang="en-US" sz="1400" b="1" dirty="0">
-                <a:solidFill>
-                  <a:srgbClr val="1F2933"/>
-                </a:solidFill>
-                <a:latin typeface="Malgun Gothic" pitchFamily="34" charset="0"/>
-                <a:ea typeface="Malgun Gothic" pitchFamily="34" charset="-122"/>
-                <a:cs typeface="Malgun Gothic" pitchFamily="34" charset="-120"/>
-              </a:rPr>
-              <a:t>재랭킹 효과</a:t>
-            </a:r>
-            <a:endParaRPr lang="en-US" sz="1400" dirty="0"/>
-          </a:p>
-        </p:txBody>
-      </p:sp>
-      <p:sp>
-        <p:nvSpPr>
-          <p:cNvPr id="25" name="Text 23"/>
-          <p:cNvSpPr txBox="1"/>
-          <p:nvPr/>
-        </p:nvSpPr>
-        <p:spPr>
-          <a:xfrm>
-            <a:off x="8371637" y="5230368"/>
-            <a:ext cx="3088538" cy="457200"/>
-          </a:xfrm>
-          <a:prstGeom prst="rect">
-            <a:avLst/>
-          </a:prstGeom>
-          <a:noFill/>
-          <a:ln/>
-        </p:spPr>
-        <p:txBody>
-          <a:bodyPr wrap="square" lIns="0" tIns="0" rIns="0" bIns="0" rtlCol="0" anchor="ctr"/>
-          <a:lstStyle/>
-          <a:p>
-            <a:pPr indent="0" marL="0">
-              <a:buNone/>
-            </a:pPr>
-            <a:r>
-              <a:rPr lang="en-US" sz="1100" dirty="0">
-                <a:solidFill>
-                  <a:srgbClr val="5B6673"/>
-                </a:solidFill>
-                <a:latin typeface="Malgun Gothic" pitchFamily="34" charset="0"/>
-                <a:ea typeface="Malgun Gothic" pitchFamily="34" charset="-122"/>
-                <a:cs typeface="Malgun Gothic" pitchFamily="34" charset="-120"/>
-              </a:rPr>
-              <a:t>잘못된 근거 상위노출 완화</a:t>
-            </a:r>
-            <a:endParaRPr lang="en-US" sz="1100" dirty="0"/>
           </a:p>
         </p:txBody>
       </p:sp>

</xml_diff>